<commit_message>
cnab_converter atualizado para novos tipos de recebiveis
</commit_message>
<xml_diff>
--- a/Apresentacao_Diretoria_Carmel_Capital.pptx
+++ b/Apresentacao_Diretoria_Carmel_Capital.pptx
@@ -12684,8 +12684,8 @@
 </file>
 
 <file path=customXml/item2.xml><?xml version="1.0" encoding="utf-8"?>
-<ct:contentTypeSchema xmlns:ct="http://schemas.microsoft.com/office/2006/metadata/contentType" xmlns:ma="http://schemas.microsoft.com/office/2006/metadata/properties/metaAttributes" ct:_="" ma:_="" ma:contentTypeName="Document" ma:contentTypeID="0x010100B2F5B2064B709C4B96B2BB6BA56010CA" ma:contentTypeVersion="12" ma:contentTypeDescription="Create a new document." ma:contentTypeScope="" ma:versionID="6e77452eb2d51676985a1637b279e587">
-  <xsd:schema xmlns:xsd="http://www.w3.org/2001/XMLSchema" xmlns:xs="http://www.w3.org/2001/XMLSchema" xmlns:p="http://schemas.microsoft.com/office/2006/metadata/properties" xmlns:ns2="242e9f65-b814-4ed0-b249-7801049d5c23" xmlns:ns3="051cde21-3992-497a-b8fe-9bb2eb9c95f5" targetNamespace="http://schemas.microsoft.com/office/2006/metadata/properties" ma:root="true" ma:fieldsID="5651a2f29d7f5045b92107f105f1c6b0" ns2:_="" ns3:_="">
+<ct:contentTypeSchema xmlns:ct="http://schemas.microsoft.com/office/2006/metadata/contentType" xmlns:ma="http://schemas.microsoft.com/office/2006/metadata/properties/metaAttributes" ct:_="" ma:_="" ma:contentTypeName="Documento" ma:contentTypeID="0x010100B2F5B2064B709C4B96B2BB6BA56010CA" ma:contentTypeVersion="12" ma:contentTypeDescription="Crie um novo documento." ma:contentTypeScope="" ma:versionID="c75267e45ffc441626e65edd1879c154">
+  <xsd:schema xmlns:xsd="http://www.w3.org/2001/XMLSchema" xmlns:xs="http://www.w3.org/2001/XMLSchema" xmlns:p="http://schemas.microsoft.com/office/2006/metadata/properties" xmlns:ns2="242e9f65-b814-4ed0-b249-7801049d5c23" xmlns:ns3="051cde21-3992-497a-b8fe-9bb2eb9c95f5" targetNamespace="http://schemas.microsoft.com/office/2006/metadata/properties" ma:root="true" ma:fieldsID="5ce575aedca7f38b5bea02731dab9aa4" ns2:_="" ns3:_="">
     <xsd:import namespace="242e9f65-b814-4ed0-b249-7801049d5c23"/>
     <xsd:import namespace="051cde21-3992-497a-b8fe-9bb2eb9c95f5"/>
     <xsd:element name="properties">
@@ -12735,7 +12735,7 @@
         <xsd:restriction base="dms:Text"/>
       </xsd:simpleType>
     </xsd:element>
-    <xsd:element name="lcf76f155ced4ddcb4097134ff3c332f" ma:index="13" nillable="true" ma:taxonomy="true" ma:internalName="lcf76f155ced4ddcb4097134ff3c332f" ma:taxonomyFieldName="MediaServiceImageTags" ma:displayName="Image Tags" ma:readOnly="false" ma:fieldId="{5cf76f15-5ced-4ddc-b409-7134ff3c332f}" ma:taxonomyMulti="true" ma:sspId="394d2bc3-e22e-42db-b4dd-8ec92871baac" ma:termSetId="09814cd3-568e-fe90-9814-8d621ff8fb84" ma:anchorId="fba54fb3-c3e1-fe81-a776-ca4b69148c4d" ma:open="true" ma:isKeyword="false">
+    <xsd:element name="lcf76f155ced4ddcb4097134ff3c332f" ma:index="13" nillable="true" ma:taxonomy="true" ma:internalName="lcf76f155ced4ddcb4097134ff3c332f" ma:taxonomyFieldName="MediaServiceImageTags" ma:displayName="Marcações de imagem" ma:readOnly="false" ma:fieldId="{5cf76f15-5ced-4ddc-b409-7134ff3c332f}" ma:taxonomyMulti="true" ma:sspId="394d2bc3-e22e-42db-b4dd-8ec92871baac" ma:termSetId="09814cd3-568e-fe90-9814-8d621ff8fb84" ma:anchorId="fba54fb3-c3e1-fe81-a776-ca4b69148c4d" ma:open="true" ma:isKeyword="false">
       <xsd:complexType>
         <xsd:sequence>
           <xsd:element ref="pc:Terms" minOccurs="0" maxOccurs="1"/>
@@ -12794,8 +12794,8 @@
         <xsd:element ref="dc:creator" minOccurs="0" maxOccurs="1"/>
         <xsd:element ref="dcterms:created" minOccurs="0" maxOccurs="1"/>
         <xsd:element ref="dc:identifier" minOccurs="0" maxOccurs="1"/>
-        <xsd:element name="contentType" minOccurs="0" maxOccurs="1" type="xsd:string" ma:index="0" ma:displayName="Content Type"/>
-        <xsd:element ref="dc:title" minOccurs="0" maxOccurs="1" ma:index="4" ma:displayName="Title"/>
+        <xsd:element name="contentType" minOccurs="0" maxOccurs="1" type="xsd:string" ma:index="0" ma:displayName="Tipo de Conteúdo"/>
+        <xsd:element ref="dc:title" minOccurs="0" maxOccurs="1" ma:index="4" ma:displayName="Título"/>
         <xsd:element ref="dc:subject" minOccurs="0" maxOccurs="1"/>
         <xsd:element ref="dc:description" minOccurs="0" maxOccurs="1"/>
         <xsd:element name="keywords" minOccurs="0" maxOccurs="1" type="xsd:string"/>
@@ -12905,22 +12905,7 @@
 </file>
 
 <file path=customXml/itemProps2.xml><?xml version="1.0" encoding="utf-8"?>
-<ds:datastoreItem xmlns:ds="http://schemas.openxmlformats.org/officeDocument/2006/customXml" ds:itemID="{6FCBDA45-5C35-4352-823D-7730238A3D2C}">
-  <ds:schemaRefs>
-    <ds:schemaRef ds:uri="http://schemas.microsoft.com/office/2006/metadata/contentType"/>
-    <ds:schemaRef ds:uri="http://schemas.microsoft.com/office/2006/metadata/properties/metaAttributes"/>
-    <ds:schemaRef ds:uri="http://www.w3.org/2001/XMLSchema"/>
-    <ds:schemaRef ds:uri="http://schemas.microsoft.com/office/2006/metadata/properties"/>
-    <ds:schemaRef ds:uri="242e9f65-b814-4ed0-b249-7801049d5c23"/>
-    <ds:schemaRef ds:uri="051cde21-3992-497a-b8fe-9bb2eb9c95f5"/>
-    <ds:schemaRef ds:uri="http://schemas.microsoft.com/office/2006/documentManagement/types"/>
-    <ds:schemaRef ds:uri="http://schemas.microsoft.com/office/infopath/2007/PartnerControls"/>
-    <ds:schemaRef ds:uri="http://schemas.openxmlformats.org/package/2006/metadata/core-properties"/>
-    <ds:schemaRef ds:uri="http://purl.org/dc/elements/1.1/"/>
-    <ds:schemaRef ds:uri="http://purl.org/dc/terms/"/>
-    <ds:schemaRef ds:uri="http://schemas.microsoft.com/internal/obd"/>
-  </ds:schemaRefs>
-</ds:datastoreItem>
+<ds:datastoreItem xmlns:ds="http://schemas.openxmlformats.org/officeDocument/2006/customXml" ds:itemID="{C319DE8B-E8CC-40B3-B385-B864D7D3DD74}"/>
 </file>
 
 <file path=customXml/itemProps3.xml><?xml version="1.0" encoding="utf-8"?>

</xml_diff>